<commit_message>
Remove em-dashes everywhere and restore the mission playback in the video
All em-dashes in the reports, README, slides, and rendered video text
are rewritten with commas, colons, or parentheses; both reports still
compile to their required 8 and 2 pages. The one-minute demo video gets
the animated mission playback back as its own segment: after the
pipeline output scrolls, a window plays the recorded dynamic-hazard
mission step by step (path growing, gas drifting, lava spreading, live
stats) before the final mission map and the baseline comparison.
</commit_message>
<xml_diff>
--- a/others/final_presentation.pptx
+++ b/others/final_presentation.pptx
@@ -3132,7 +3132,7 @@
                   <a:srgbClr val="9FB2C8"/>
                 </a:solidFill>
               </a:rPr>
-              <a:t>Group 5  —  Shakil Ahmed  ·  Fahim Foysal  ·  Shefa Tabassum  ·  Tanvir Ahmed</a:t>
+              <a:t>Group 5  |  Shakil Ahmed  ·  Fahim Foysal  ·  Shefa Tabassum  ·  Tanvir Ahmed</a:t>
             </a:r>
           </a:p>
         </p:txBody>
@@ -3275,7 +3275,7 @@
                   <a:srgbClr val="9FB2C8"/>
                 </a:solidFill>
               </a:rPr>
-              <a:t>CSE 440 — Artificial Intelligence  ·  Section 1  ·  Instructor: Dr. Mohammad Shifat-E-Rabbi</a:t>
+              <a:t>CSE 440 (Artificial Intelligence)  ·  Section 1  ·  Instructor: Dr. Mohammad Shifat-E-Rabbi</a:t>
             </a:r>
           </a:p>
         </p:txBody>
@@ -3334,7 +3334,7 @@
                   <a:srgbClr val="606670"/>
                 </a:solidFill>
               </a:rPr>
-              <a:t>Group 5  —  Shakil Ahmed  ·  Fahim Foysal  ·  Shefa Tabassum  ·  Tanvir Ahmed</a:t>
+              <a:t>Group 5  |  Shakil Ahmed  ·  Fahim Foysal  ·  Shefa Tabassum  ·  Tanvir Ahmed</a:t>
             </a:r>
           </a:p>
         </p:txBody>
@@ -3455,7 +3455,7 @@
                   <a:srgbClr val="20242B"/>
                 </a:solidFill>
               </a:rPr>
-              <a:t>•  Movement is unreliable — the rover can slip sideways or stall</a:t>
+              <a:t>•  Movement is unreliable: the rover can slip sideways or stall</a:t>
             </a:r>
           </a:p>
           <a:p>
@@ -3553,7 +3553,7 @@
                   <a:srgbClr val="606670"/>
                 </a:solidFill>
               </a:rPr>
-              <a:t>Group 5  —  Shakil Ahmed  ·  Fahim Foysal  ·  Shefa Tabassum  ·  Tanvir Ahmed</a:t>
+              <a:t>Group 5  |  Shakil Ahmed  ·  Fahim Foysal  ·  Shefa Tabassum  ·  Tanvir Ahmed</a:t>
             </a:r>
           </a:p>
         </p:txBody>
@@ -3689,7 +3689,7 @@
                   <a:srgbClr val="20242B"/>
                 </a:solidFill>
               </a:rPr>
-              <a:t>•  Discount γ = 0.9 — tuned so distant science never justifies deadly gambles</a:t>
+              <a:t>•  Discount γ = 0.9, tuned so distant science never justifies deadly gambles</a:t>
             </a:r>
           </a:p>
           <a:p>
@@ -3816,7 +3816,7 @@
                   <a:srgbClr val="606670"/>
                 </a:solidFill>
               </a:rPr>
-              <a:t>Group 5  —  Shakil Ahmed  ·  Fahim Foysal  ·  Shefa Tabassum  ·  Tanvir Ahmed</a:t>
+              <a:t>Group 5  |  Shakil Ahmed  ·  Fahim Foysal  ·  Shefa Tabassum  ·  Tanvir Ahmed</a:t>
             </a:r>
           </a:p>
         </p:txBody>
@@ -3892,7 +3892,7 @@
                   <a:srgbClr val="20242B"/>
                 </a:solidFill>
               </a:rPr>
-              <a:t>•  One optimal action per cell — a complete plan, not a single path</a:t>
+              <a:t>•  One optimal action per cell: a complete plan, not a single path</a:t>
             </a:r>
           </a:p>
           <a:p>
@@ -4020,7 +4020,7 @@
                   <a:srgbClr val="606670"/>
                 </a:solidFill>
               </a:rPr>
-              <a:t>Group 5  —  Shakil Ahmed  ·  Fahim Foysal  ·  Shefa Tabassum  ·  Tanvir Ahmed</a:t>
+              <a:t>Group 5  |  Shakil Ahmed  ·  Fahim Foysal  ·  Shefa Tabassum  ·  Tanvir Ahmed</a:t>
             </a:r>
           </a:p>
         </p:txBody>
@@ -4111,7 +4111,7 @@
                   <a:srgbClr val="20242B"/>
                 </a:solidFill>
               </a:rPr>
-              <a:t>•  Our rule: a sample is collected once — the cell becomes ordinary ground</a:t>
+              <a:t>•  Our rule: a sample is collected once, then the cell becomes ordinary ground</a:t>
             </a:r>
           </a:p>
           <a:p>
@@ -4200,7 +4200,7 @@
                   <a:srgbClr val="606670"/>
                 </a:solidFill>
               </a:rPr>
-              <a:t>Group 5  —  Shakil Ahmed  ·  Fahim Foysal  ·  Shefa Tabassum  ·  Tanvir Ahmed</a:t>
+              <a:t>Group 5  |  Shakil Ahmed  ·  Fahim Foysal  ·  Shefa Tabassum  ·  Tanvir Ahmed</a:t>
             </a:r>
           </a:p>
         </p:txBody>
@@ -4306,7 +4306,7 @@
                   <a:srgbClr val="20242B"/>
                 </a:solidFill>
               </a:rPr>
-              <a:t>•  Base, science, rock, and craters are never destroyed — state space stays fixed</a:t>
+              <a:t>•  Base, science, rock, and craters are never destroyed, so the state space stays fixed</a:t>
             </a:r>
           </a:p>
           <a:p>
@@ -4481,7 +4481,7 @@
                   <a:srgbClr val="606670"/>
                 </a:solidFill>
               </a:rPr>
-              <a:t>Group 5  —  Shakil Ahmed  ·  Fahim Foysal  ·  Shefa Tabassum  ·  Tanvir Ahmed</a:t>
+              <a:t>Group 5  |  Shakil Ahmed  ·  Fahim Foysal  ·  Shefa Tabassum  ·  Tanvir Ahmed</a:t>
             </a:r>
           </a:p>
         </p:txBody>
@@ -4602,7 +4602,7 @@
                   <a:srgbClr val="20242B"/>
                 </a:solidFill>
               </a:rPr>
-              <a:t>•  Reward higher than the static run of the same seed — re-planning exploited a gas cloud drifting off its route</a:t>
+              <a:t>•  Reward higher than the static run of the same seed: re-planning exploited a gas cloud drifting off its route</a:t>
             </a:r>
           </a:p>
         </p:txBody>
@@ -4685,7 +4685,7 @@
                   <a:srgbClr val="606670"/>
                 </a:solidFill>
               </a:rPr>
-              <a:t>Group 5  —  Shakil Ahmed  ·  Fahim Foysal  ·  Shefa Tabassum  ·  Tanvir Ahmed</a:t>
+              <a:t>Group 5  |  Shakil Ahmed  ·  Fahim Foysal  ·  Shefa Tabassum  ·  Tanvir Ahmed</a:t>
             </a:r>
           </a:p>
         </p:txBody>
@@ -4776,7 +4776,7 @@
                   <a:srgbClr val="20242B"/>
                 </a:solidFill>
               </a:rPr>
-              <a:t>•  Greedy: BFS to nearest unvisited cell — ignores soft hazards</a:t>
+              <a:t>•  Greedy: BFS to nearest unvisited cell, ignoring soft hazards</a:t>
             </a:r>
           </a:p>
           <a:p>
@@ -4821,7 +4821,7 @@
                   <a:srgbClr val="20242B"/>
                 </a:solidFill>
               </a:rPr>
-              <a:t>•  It survives 60% of missions — 2× greedy — with ~5× fewer hazard entries</a:t>
+              <a:t>•  It survives 60% of missions (2× greedy) with ~5× fewer hazard entries</a:t>
             </a:r>
           </a:p>
         </p:txBody>
@@ -4904,7 +4904,7 @@
                   <a:srgbClr val="606670"/>
                 </a:solidFill>
               </a:rPr>
-              <a:t>Group 5  —  Shakil Ahmed  ·  Fahim Foysal  ·  Shefa Tabassum  ·  Tanvir Ahmed</a:t>
+              <a:t>Group 5  |  Shakil Ahmed  ·  Fahim Foysal  ·  Shefa Tabassum  ·  Tanvir Ahmed</a:t>
             </a:r>
           </a:p>
         </p:txBody>
@@ -4995,7 +4995,7 @@
                   <a:srgbClr val="20242B"/>
                 </a:solidFill>
               </a:rPr>
-              <a:t>•  Safety and science behavior emerge from the reward model — no hand-coded rules</a:t>
+              <a:t>•  Safety and science behavior emerge from the reward model, with no hand-coded rules</a:t>
             </a:r>
           </a:p>
           <a:p>

</xml_diff>